<commit_message>
slides(course): regenerate claude-tool-use-from-zero ch06 deck title slide
</commit_message>
<xml_diff>
--- a/vault/courses/claude-tool-use-from-zero/ch06-slides.pptx
+++ b/vault/courses/claude-tool-use-from-zero/ch06-slides.pptx
@@ -13,7 +13,7 @@
     <p:sldId id="261" r:id="rId12"/>
     <p:sldId id="262" r:id="rId13"/>
   </p:sldIdLst>
-  <p:sldSz cx="14630400" cy="8229600" type="screen4x3"/>
+  <p:sldSz cx="12191695" cy="6858000" type="screen4x3"/>
   <p:notesSz cx="6858000" cy="9144000"/>
   <p:defaultTextStyle>
     <a:defPPr>
@@ -3104,57 +3104,14 @@
       <p:grpSpPr/>
       <p:sp>
         <p:nvSpPr>
-          <p:cNvPr id="2" name="Rectangle 1"/>
-          <p:cNvSpPr/>
-          <p:nvPr/>
-        </p:nvSpPr>
-        <p:spPr>
-          <a:xfrm>
-            <a:off x="0" y="0"/>
-            <a:ext cx="146304" cy="8229600"/>
-          </a:xfrm>
-          <a:prstGeom prst="rect">
-            <a:avLst/>
-          </a:prstGeom>
-          <a:solidFill>
-            <a:srgbClr val="38BDF8"/>
-          </a:solidFill>
-          <a:ln>
-            <a:noFill/>
-          </a:ln>
-        </p:spPr>
-        <p:style>
-          <a:lnRef idx="1">
-            <a:schemeClr val="accent1"/>
-          </a:lnRef>
-          <a:fillRef idx="3">
-            <a:schemeClr val="accent1"/>
-          </a:fillRef>
-          <a:effectRef idx="2">
-            <a:schemeClr val="accent1"/>
-          </a:effectRef>
-          <a:fontRef idx="minor">
-            <a:schemeClr val="lt1"/>
-          </a:fontRef>
-        </p:style>
-        <p:txBody>
-          <a:bodyPr rtlCol="0" anchor="ctr"/>
-          <a:lstStyle/>
-          <a:p>
-            <a:pPr algn="ctr"/>
-          </a:p>
-        </p:txBody>
-      </p:sp>
-      <p:sp>
-        <p:nvSpPr>
-          <p:cNvPr id="3" name="TextBox 2"/>
+          <p:cNvPr id="2" name="TextBox 1"/>
           <p:cNvSpPr txBox="1"/>
           <p:nvPr/>
         </p:nvSpPr>
         <p:spPr>
           <a:xfrm>
-            <a:off x="731520" y="1143000"/>
-            <a:ext cx="12984480" cy="868680"/>
+            <a:off x="914400" y="1828800"/>
+            <a:ext cx="10332720" cy="2286000"/>
           </a:xfrm>
           <a:prstGeom prst="rect">
             <a:avLst/>
@@ -3162,32 +3119,33 @@
           <a:noFill/>
         </p:spPr>
         <p:txBody>
-          <a:bodyPr wrap="none">
+          <a:bodyPr wrap="square">
             <a:spAutoFit/>
           </a:bodyPr>
           <a:lstStyle/>
           <a:p>
-            <a:r>
-              <a:rPr b="1" sz="4300">
+            <a:pPr algn="ctr"/>
+            <a:r>
+              <a:rPr sz="3400" b="1">
                 <a:solidFill>
                   <a:srgbClr val="FFFFFF"/>
                 </a:solidFill>
               </a:rPr>
-              <a:t>Security and Authentication: Hardening Your MCP Connectors</a:t>
-            </a:r>
-          </a:p>
-        </p:txBody>
-      </p:sp>
-      <p:sp>
-        <p:nvSpPr>
-          <p:cNvPr id="4" name="TextBox 3"/>
+              <a:t>Security and Authentication</a:t>
+            </a:r>
+          </a:p>
+        </p:txBody>
+      </p:sp>
+      <p:sp>
+        <p:nvSpPr>
+          <p:cNvPr id="3" name="TextBox 2"/>
           <p:cNvSpPr txBox="1"/>
           <p:nvPr/>
         </p:nvSpPr>
         <p:spPr>
           <a:xfrm>
-            <a:off x="786384" y="2286000"/>
-            <a:ext cx="12801600" cy="502920"/>
+            <a:off x="731520" y="6263640"/>
+            <a:ext cx="10698480" cy="365760"/>
           </a:xfrm>
           <a:prstGeom prst="rect">
             <a:avLst/>
@@ -3195,115 +3153,14 @@
           <a:noFill/>
         </p:spPr>
         <p:txBody>
-          <a:bodyPr wrap="none">
+          <a:bodyPr wrap="square">
             <a:spAutoFit/>
           </a:bodyPr>
           <a:lstStyle/>
           <a:p>
-            <a:r>
-              <a:rPr sz="2400">
-                <a:solidFill>
-                  <a:srgbClr val="A1A1AA"/>
-                </a:solidFill>
-              </a:rPr>
-              <a:t>Chapter 6 · Claude Tool Use from Zero</a:t>
-            </a:r>
-          </a:p>
-        </p:txBody>
-      </p:sp>
-      <p:sp>
-        <p:nvSpPr>
-          <p:cNvPr id="5" name="TextBox 4"/>
-          <p:cNvSpPr txBox="1"/>
-          <p:nvPr/>
-        </p:nvSpPr>
-        <p:spPr>
-          <a:xfrm>
-            <a:off x="914400" y="3246120"/>
-            <a:ext cx="12801600" cy="5212080"/>
-          </a:xfrm>
-          <a:prstGeom prst="rect">
-            <a:avLst/>
-          </a:prstGeom>
-          <a:noFill/>
-        </p:spPr>
-        <p:txBody>
-          <a:bodyPr wrap="none">
-            <a:spAutoFit/>
-          </a:bodyPr>
-          <a:lstStyle/>
-          <a:p>
-            <a:pPr>
-              <a:spcAft>
-                <a:spcPts val="1500"/>
-              </a:spcAft>
-              <a:defRPr sz="2500">
-                <a:solidFill>
-                  <a:srgbClr val="FFFFFF"/>
-                </a:solidFill>
-              </a:defRPr>
-            </a:pPr>
-            <a:r>
-              <a:t>Security shifts from the model weights to the connector design.</a:t>
-            </a:r>
-          </a:p>
-          <a:p>
-            <a:pPr>
-              <a:spcAft>
-                <a:spcPts val="1500"/>
-              </a:spcAft>
-              <a:defRPr sz="2500">
-                <a:solidFill>
-                  <a:srgbClr val="FFFFFF"/>
-                </a:solidFill>
-              </a:defRPr>
-            </a:pPr>
-            <a:r>
-              <a:t>The goal is making tools safe, not just making tools work.</a:t>
-            </a:r>
-          </a:p>
-          <a:p>
-            <a:pPr>
-              <a:spcAft>
-                <a:spcPts val="1500"/>
-              </a:spcAft>
-              <a:defRPr sz="2500">
-                <a:solidFill>
-                  <a:srgbClr val="FFFFFF"/>
-                </a:solidFill>
-              </a:defRPr>
-            </a:pPr>
-            <a:r>
-              <a:t>academy.kspl.tech | Koenig AI Academy</a:t>
-            </a:r>
-          </a:p>
-        </p:txBody>
-      </p:sp>
-      <p:sp>
-        <p:nvSpPr>
-          <p:cNvPr id="6" name="TextBox 5"/>
-          <p:cNvSpPr txBox="1"/>
-          <p:nvPr/>
-        </p:nvSpPr>
-        <p:spPr>
-          <a:xfrm>
-            <a:off x="594360" y="7662672"/>
-            <a:ext cx="13441680" cy="256032"/>
-          </a:xfrm>
-          <a:prstGeom prst="rect">
-            <a:avLst/>
-          </a:prstGeom>
-          <a:noFill/>
-        </p:spPr>
-        <p:txBody>
-          <a:bodyPr wrap="none">
-            <a:spAutoFit/>
-          </a:bodyPr>
-          <a:lstStyle/>
-          <a:p>
-            <a:pPr algn="r"/>
-            <a:r>
-              <a:rPr sz="1100">
+            <a:pPr algn="l"/>
+            <a:r>
+              <a:rPr sz="1000" b="0">
                 <a:solidFill>
                   <a:srgbClr val="A1A1AA"/>
                 </a:solidFill>
@@ -3341,20 +3198,54 @@
       <p:grpSpPr/>
       <p:sp>
         <p:nvSpPr>
-          <p:cNvPr id="2" name="Rectangle 1"/>
+          <p:cNvPr id="2" name="TextBox 1"/>
+          <p:cNvSpPr txBox="1"/>
+          <p:nvPr/>
+        </p:nvSpPr>
+        <p:spPr>
+          <a:xfrm>
+            <a:off x="731520" y="411480"/>
+            <a:ext cx="10698480" cy="1005840"/>
+          </a:xfrm>
+          <a:prstGeom prst="rect">
+            <a:avLst/>
+          </a:prstGeom>
+          <a:noFill/>
+        </p:spPr>
+        <p:txBody>
+          <a:bodyPr wrap="square">
+            <a:spAutoFit/>
+          </a:bodyPr>
+          <a:lstStyle/>
+          <a:p>
+            <a:pPr algn="l"/>
+            <a:r>
+              <a:rPr sz="2800" b="1">
+                <a:solidFill>
+                  <a:srgbClr val="FFFFFF"/>
+                </a:solidFill>
+              </a:rPr>
+              <a:t>Prerequisites check</a:t>
+            </a:r>
+          </a:p>
+        </p:txBody>
+      </p:sp>
+      <p:sp>
+        <p:nvSpPr>
+          <p:cNvPr id="3" name="Rectangle 2"/>
           <p:cNvSpPr/>
           <p:nvPr/>
         </p:nvSpPr>
         <p:spPr>
           <a:xfrm>
-            <a:off x="0" y="0"/>
-            <a:ext cx="146304" cy="8229600"/>
+            <a:off x="731520" y="1417320"/>
+            <a:ext cx="10698480" cy="36576"/>
           </a:xfrm>
           <a:prstGeom prst="rect">
             <a:avLst/>
           </a:prstGeom>
           <a:solidFill>
-            <a:srgbClr val="38BDF8"/>
+            <a:srgbClr val="A1A1AA"/>
           </a:solidFill>
           <a:ln>
             <a:noFill/>
@@ -3384,14 +3275,14 @@
       </p:sp>
       <p:sp>
         <p:nvSpPr>
-          <p:cNvPr id="3" name="TextBox 2"/>
+          <p:cNvPr id="4" name="TextBox 3"/>
           <p:cNvSpPr txBox="1"/>
           <p:nvPr/>
         </p:nvSpPr>
         <p:spPr>
           <a:xfrm>
-            <a:off x="731520" y="594360"/>
-            <a:ext cx="12984480" cy="868680"/>
+            <a:off x="731520" y="1600200"/>
+            <a:ext cx="10698480" cy="960120"/>
           </a:xfrm>
           <a:prstGeom prst="rect">
             <a:avLst/>
@@ -3399,32 +3290,33 @@
           <a:noFill/>
         </p:spPr>
         <p:txBody>
-          <a:bodyPr wrap="none">
+          <a:bodyPr wrap="square">
             <a:spAutoFit/>
           </a:bodyPr>
           <a:lstStyle/>
           <a:p>
-            <a:r>
-              <a:rPr b="1" sz="4000">
+            <a:pPr algn="l"/>
+            <a:r>
+              <a:rPr sz="1700" b="0">
                 <a:solidFill>
                   <a:srgbClr val="FFFFFF"/>
                 </a:solidFill>
               </a:rPr>
-              <a:t>Why Security Is the MCP Bottleneck</a:t>
-            </a:r>
-          </a:p>
-        </p:txBody>
-      </p:sp>
-      <p:sp>
-        <p:nvSpPr>
-          <p:cNvPr id="4" name="TextBox 3"/>
+              <a:t>  You need the structured logs from Chapter 5. If a tool call is not logged, you cannot audit security behavior...</a:t>
+            </a:r>
+          </a:p>
+        </p:txBody>
+      </p:sp>
+      <p:sp>
+        <p:nvSpPr>
+          <p:cNvPr id="5" name="TextBox 4"/>
           <p:cNvSpPr txBox="1"/>
           <p:nvPr/>
         </p:nvSpPr>
         <p:spPr>
           <a:xfrm>
-            <a:off x="914400" y="1828800"/>
-            <a:ext cx="12801600" cy="5212080"/>
+            <a:off x="731520" y="6263640"/>
+            <a:ext cx="10698480" cy="365760"/>
           </a:xfrm>
           <a:prstGeom prst="rect">
             <a:avLst/>
@@ -3432,97 +3324,14 @@
           <a:noFill/>
         </p:spPr>
         <p:txBody>
-          <a:bodyPr wrap="none">
+          <a:bodyPr wrap="square">
             <a:spAutoFit/>
           </a:bodyPr>
           <a:lstStyle/>
           <a:p>
-            <a:pPr>
-              <a:spcAft>
-                <a:spcPts val="1500"/>
-              </a:spcAft>
-              <a:defRPr sz="2500">
-                <a:solidFill>
-                  <a:srgbClr val="FFFFFF"/>
-                </a:solidFill>
-              </a:defRPr>
-            </a:pPr>
-            <a:r>
-              <a:t>MCP flexibility can become liability when a tool has excessive permissions.</a:t>
-            </a:r>
-          </a:p>
-          <a:p>
-            <a:pPr>
-              <a:spcAft>
-                <a:spcPts val="1500"/>
-              </a:spcAft>
-              <a:defRPr sz="2500">
-                <a:solidFill>
-                  <a:srgbClr val="FFFFFF"/>
-                </a:solidFill>
-              </a:defRPr>
-            </a:pPr>
-            <a:r>
-              <a:t>A broad read-file tool can leak credentials through indirect prompt injection.</a:t>
-            </a:r>
-          </a:p>
-          <a:p>
-            <a:pPr>
-              <a:spcAft>
-                <a:spcPts val="1500"/>
-              </a:spcAft>
-              <a:defRPr sz="2500">
-                <a:solidFill>
-                  <a:srgbClr val="FFFFFF"/>
-                </a:solidFill>
-              </a:defRPr>
-            </a:pPr>
-            <a:r>
-              <a:t>API keys are not enough; connectors need contextual authorization.</a:t>
-            </a:r>
-          </a:p>
-          <a:p>
-            <a:pPr>
-              <a:spcAft>
-                <a:spcPts val="1500"/>
-              </a:spcAft>
-              <a:defRPr sz="2500">
-                <a:solidFill>
-                  <a:srgbClr val="FFFFFF"/>
-                </a:solidFill>
-              </a:defRPr>
-            </a:pPr>
-            <a:r>
-              <a:t>Agents should only reach the tools and data required for the current task.</a:t>
-            </a:r>
-          </a:p>
-        </p:txBody>
-      </p:sp>
-      <p:sp>
-        <p:nvSpPr>
-          <p:cNvPr id="5" name="TextBox 4"/>
-          <p:cNvSpPr txBox="1"/>
-          <p:nvPr/>
-        </p:nvSpPr>
-        <p:spPr>
-          <a:xfrm>
-            <a:off x="594360" y="7662672"/>
-            <a:ext cx="13441680" cy="256032"/>
-          </a:xfrm>
-          <a:prstGeom prst="rect">
-            <a:avLst/>
-          </a:prstGeom>
-          <a:noFill/>
-        </p:spPr>
-        <p:txBody>
-          <a:bodyPr wrap="none">
-            <a:spAutoFit/>
-          </a:bodyPr>
-          <a:lstStyle/>
-          <a:p>
-            <a:pPr algn="r"/>
-            <a:r>
-              <a:rPr sz="1100">
+            <a:pPr algn="l"/>
+            <a:r>
+              <a:rPr sz="1000" b="0">
                 <a:solidFill>
                   <a:srgbClr val="A1A1AA"/>
                 </a:solidFill>
@@ -3560,20 +3369,54 @@
       <p:grpSpPr/>
       <p:sp>
         <p:nvSpPr>
-          <p:cNvPr id="2" name="Rectangle 1"/>
+          <p:cNvPr id="2" name="TextBox 1"/>
+          <p:cNvSpPr txBox="1"/>
+          <p:nvPr/>
+        </p:nvSpPr>
+        <p:spPr>
+          <a:xfrm>
+            <a:off x="731520" y="411480"/>
+            <a:ext cx="10698480" cy="1005840"/>
+          </a:xfrm>
+          <a:prstGeom prst="rect">
+            <a:avLst/>
+          </a:prstGeom>
+          <a:noFill/>
+        </p:spPr>
+        <p:txBody>
+          <a:bodyPr wrap="square">
+            <a:spAutoFit/>
+          </a:bodyPr>
+          <a:lstStyle/>
+          <a:p>
+            <a:pPr algn="l"/>
+            <a:r>
+              <a:rPr sz="2800" b="1">
+                <a:solidFill>
+                  <a:srgbClr val="FFFFFF"/>
+                </a:solidFill>
+              </a:rPr>
+              <a:t>Authentication vs authorization</a:t>
+            </a:r>
+          </a:p>
+        </p:txBody>
+      </p:sp>
+      <p:sp>
+        <p:nvSpPr>
+          <p:cNvPr id="3" name="Rectangle 2"/>
           <p:cNvSpPr/>
           <p:nvPr/>
         </p:nvSpPr>
         <p:spPr>
           <a:xfrm>
-            <a:off x="0" y="0"/>
-            <a:ext cx="146304" cy="8229600"/>
+            <a:off x="731520" y="1417320"/>
+            <a:ext cx="10698480" cy="36576"/>
           </a:xfrm>
           <a:prstGeom prst="rect">
             <a:avLst/>
           </a:prstGeom>
           <a:solidFill>
-            <a:srgbClr val="38BDF8"/>
+            <a:srgbClr val="A1A1AA"/>
           </a:solidFill>
           <a:ln>
             <a:noFill/>
@@ -3603,14 +3446,14 @@
       </p:sp>
       <p:sp>
         <p:nvSpPr>
-          <p:cNvPr id="3" name="TextBox 2"/>
+          <p:cNvPr id="4" name="TextBox 3"/>
           <p:cNvSpPr txBox="1"/>
           <p:nvPr/>
         </p:nvSpPr>
         <p:spPr>
           <a:xfrm>
-            <a:off x="731520" y="594360"/>
-            <a:ext cx="12984480" cy="868680"/>
+            <a:off x="731520" y="1600200"/>
+            <a:ext cx="10698480" cy="960120"/>
           </a:xfrm>
           <a:prstGeom prst="rect">
             <a:avLst/>
@@ -3618,32 +3461,33 @@
           <a:noFill/>
         </p:spPr>
         <p:txBody>
-          <a:bodyPr wrap="none">
+          <a:bodyPr wrap="square">
             <a:spAutoFit/>
           </a:bodyPr>
           <a:lstStyle/>
           <a:p>
-            <a:r>
-              <a:rPr b="1" sz="4000">
+            <a:pPr algn="l"/>
+            <a:r>
+              <a:rPr sz="1700" b="0">
                 <a:solidFill>
                   <a:srgbClr val="FFFFFF"/>
                 </a:solidFill>
               </a:rPr>
-              <a:t>Apply Least Privilege to Tool Design</a:t>
-            </a:r>
-          </a:p>
-        </p:txBody>
-      </p:sp>
-      <p:sp>
-        <p:nvSpPr>
-          <p:cNvPr id="4" name="TextBox 3"/>
+              <a:t>  Authentication answers "who is calling?" Authorization answers "may this caller do this action to this...</a:t>
+            </a:r>
+          </a:p>
+        </p:txBody>
+      </p:sp>
+      <p:sp>
+        <p:nvSpPr>
+          <p:cNvPr id="5" name="TextBox 4"/>
           <p:cNvSpPr txBox="1"/>
           <p:nvPr/>
         </p:nvSpPr>
         <p:spPr>
           <a:xfrm>
-            <a:off x="914400" y="1828800"/>
-            <a:ext cx="12801600" cy="5212080"/>
+            <a:off x="731520" y="2651760"/>
+            <a:ext cx="10698480" cy="960120"/>
           </a:xfrm>
           <a:prstGeom prst="rect">
             <a:avLst/>
@@ -3651,82 +3495,33 @@
           <a:noFill/>
         </p:spPr>
         <p:txBody>
-          <a:bodyPr wrap="none">
+          <a:bodyPr wrap="square">
             <a:spAutoFit/>
           </a:bodyPr>
           <a:lstStyle/>
           <a:p>
-            <a:pPr>
-              <a:spcAft>
-                <a:spcPts val="1500"/>
-              </a:spcAft>
-              <a:defRPr sz="2500">
+            <a:pPr algn="l"/>
+            <a:r>
+              <a:rPr sz="1700" b="0">
                 <a:solidFill>
                   <a:srgbClr val="FFFFFF"/>
                 </a:solidFill>
-              </a:defRPr>
-            </a:pPr>
-            <a:r>
-              <a:t>Replace generic tools such as sql_query with task-specific operations.</a:t>
-            </a:r>
-          </a:p>
-          <a:p>
-            <a:pPr>
-              <a:spcAft>
-                <a:spcPts val="1500"/>
-              </a:spcAft>
-              <a:defRPr sz="2500">
-                <a:solidFill>
-                  <a:srgbClr val="FFFFFF"/>
-                </a:solidFill>
-              </a:defRPr>
-            </a:pPr>
-            <a:r>
-              <a:t>Validate every model-supplied argument with strict JSON Schema.</a:t>
-            </a:r>
-          </a:p>
-          <a:p>
-            <a:pPr>
-              <a:spcAft>
-                <a:spcPts val="1500"/>
-              </a:spcAft>
-              <a:defRPr sz="2500">
-                <a:solidFill>
-                  <a:srgbClr val="FFFFFF"/>
-                </a:solidFill>
-              </a:defRPr>
-            </a:pPr>
-            <a:r>
-              <a:t>Sanitize inputs before calling downstream systems.</a:t>
-            </a:r>
-          </a:p>
-          <a:p>
-            <a:pPr>
-              <a:spcAft>
-                <a:spcPts val="1500"/>
-              </a:spcAft>
-              <a:defRPr sz="2500">
-                <a:solidFill>
-                  <a:srgbClr val="FFFFFF"/>
-                </a:solidFill>
-              </a:defRPr>
-            </a:pPr>
-            <a:r>
-              <a:t>Run MCP servers in restricted, ephemeral environments with narrow network access.</a:t>
-            </a:r>
-          </a:p>
-        </p:txBody>
-      </p:sp>
-      <p:sp>
-        <p:nvSpPr>
-          <p:cNvPr id="5" name="TextBox 4"/>
+              </a:rPr>
+              <a:t>  Authentication: request includes a bearer token that maps to user_123.</a:t>
+            </a:r>
+          </a:p>
+        </p:txBody>
+      </p:sp>
+      <p:sp>
+        <p:nvSpPr>
+          <p:cNvPr id="6" name="TextBox 5"/>
           <p:cNvSpPr txBox="1"/>
           <p:nvPr/>
         </p:nvSpPr>
         <p:spPr>
           <a:xfrm>
-            <a:off x="594360" y="7662672"/>
-            <a:ext cx="13441680" cy="256032"/>
+            <a:off x="731520" y="3703320"/>
+            <a:ext cx="10698480" cy="960120"/>
           </a:xfrm>
           <a:prstGeom prst="rect">
             <a:avLst/>
@@ -3734,14 +3529,82 @@
           <a:noFill/>
         </p:spPr>
         <p:txBody>
-          <a:bodyPr wrap="none">
+          <a:bodyPr wrap="square">
             <a:spAutoFit/>
           </a:bodyPr>
           <a:lstStyle/>
           <a:p>
-            <a:pPr algn="r"/>
-            <a:r>
-              <a:rPr sz="1100">
+            <a:pPr algn="l"/>
+            <a:r>
+              <a:rPr sz="1700" b="0">
+                <a:solidFill>
+                  <a:srgbClr val="FFFFFF"/>
+                </a:solidFill>
+              </a:rPr>
+              <a:t>  Authorization: user_123 may read demo project files but may not list production secrets.</a:t>
+            </a:r>
+          </a:p>
+        </p:txBody>
+      </p:sp>
+      <p:sp>
+        <p:nvSpPr>
+          <p:cNvPr id="7" name="TextBox 6"/>
+          <p:cNvSpPr txBox="1"/>
+          <p:nvPr/>
+        </p:nvSpPr>
+        <p:spPr>
+          <a:xfrm>
+            <a:off x="731520" y="4754880"/>
+            <a:ext cx="10698480" cy="960120"/>
+          </a:xfrm>
+          <a:prstGeom prst="rect">
+            <a:avLst/>
+          </a:prstGeom>
+          <a:noFill/>
+        </p:spPr>
+        <p:txBody>
+          <a:bodyPr wrap="square">
+            <a:spAutoFit/>
+          </a:bodyPr>
+          <a:lstStyle/>
+          <a:p>
+            <a:pPr algn="l"/>
+            <a:r>
+              <a:rPr sz="1700" b="0">
+                <a:solidFill>
+                  <a:srgbClr val="FFFFFF"/>
+                </a:solidFill>
+              </a:rPr>
+              <a:t>  Authentication: the MCP server receives FINANCE_API_KEY as an environment variable.</a:t>
+            </a:r>
+          </a:p>
+        </p:txBody>
+      </p:sp>
+      <p:sp>
+        <p:nvSpPr>
+          <p:cNvPr id="8" name="TextBox 7"/>
+          <p:cNvSpPr txBox="1"/>
+          <p:nvPr/>
+        </p:nvSpPr>
+        <p:spPr>
+          <a:xfrm>
+            <a:off x="731520" y="6263640"/>
+            <a:ext cx="10698480" cy="365760"/>
+          </a:xfrm>
+          <a:prstGeom prst="rect">
+            <a:avLst/>
+          </a:prstGeom>
+          <a:noFill/>
+        </p:spPr>
+        <p:txBody>
+          <a:bodyPr wrap="square">
+            <a:spAutoFit/>
+          </a:bodyPr>
+          <a:lstStyle/>
+          <a:p>
+            <a:pPr algn="l"/>
+            <a:r>
+              <a:rPr sz="1000" b="0">
                 <a:solidFill>
                   <a:srgbClr val="A1A1AA"/>
                 </a:solidFill>
@@ -3779,20 +3642,54 @@
       <p:grpSpPr/>
       <p:sp>
         <p:nvSpPr>
-          <p:cNvPr id="2" name="Rectangle 1"/>
+          <p:cNvPr id="2" name="TextBox 1"/>
+          <p:cNvSpPr txBox="1"/>
+          <p:nvPr/>
+        </p:nvSpPr>
+        <p:spPr>
+          <a:xfrm>
+            <a:off x="731520" y="411480"/>
+            <a:ext cx="10698480" cy="1005840"/>
+          </a:xfrm>
+          <a:prstGeom prst="rect">
+            <a:avLst/>
+          </a:prstGeom>
+          <a:noFill/>
+        </p:spPr>
+        <p:txBody>
+          <a:bodyPr wrap="square">
+            <a:spAutoFit/>
+          </a:bodyPr>
+          <a:lstStyle/>
+          <a:p>
+            <a:pPr algn="l"/>
+            <a:r>
+              <a:rPr sz="2800" b="1">
+                <a:solidFill>
+                  <a:srgbClr val="FFFFFF"/>
+                </a:solidFill>
+              </a:rPr>
+              <a:t>Least privilege for connectors</a:t>
+            </a:r>
+          </a:p>
+        </p:txBody>
+      </p:sp>
+      <p:sp>
+        <p:nvSpPr>
+          <p:cNvPr id="3" name="Rectangle 2"/>
           <p:cNvSpPr/>
           <p:nvPr/>
         </p:nvSpPr>
         <p:spPr>
           <a:xfrm>
-            <a:off x="0" y="0"/>
-            <a:ext cx="146304" cy="8229600"/>
+            <a:off x="731520" y="1417320"/>
+            <a:ext cx="10698480" cy="36576"/>
           </a:xfrm>
           <a:prstGeom prst="rect">
             <a:avLst/>
           </a:prstGeom>
           <a:solidFill>
-            <a:srgbClr val="38BDF8"/>
+            <a:srgbClr val="A1A1AA"/>
           </a:solidFill>
           <a:ln>
             <a:noFill/>
@@ -3822,14 +3719,14 @@
       </p:sp>
       <p:sp>
         <p:nvSpPr>
-          <p:cNvPr id="3" name="TextBox 2"/>
+          <p:cNvPr id="4" name="TextBox 3"/>
           <p:cNvSpPr txBox="1"/>
           <p:nvPr/>
         </p:nvSpPr>
         <p:spPr>
           <a:xfrm>
-            <a:off x="731520" y="594360"/>
-            <a:ext cx="12984480" cy="868680"/>
+            <a:off x="731520" y="1600200"/>
+            <a:ext cx="10698480" cy="960120"/>
           </a:xfrm>
           <a:prstGeom prst="rect">
             <a:avLst/>
@@ -3837,32 +3734,33 @@
           <a:noFill/>
         </p:spPr>
         <p:txBody>
-          <a:bodyPr wrap="none">
+          <a:bodyPr wrap="square">
             <a:spAutoFit/>
           </a:bodyPr>
           <a:lstStyle/>
           <a:p>
-            <a:r>
-              <a:rPr b="1" sz="4000">
+            <a:pPr algn="l"/>
+            <a:r>
+              <a:rPr sz="1700" b="0">
                 <a:solidFill>
                   <a:srgbClr val="FFFFFF"/>
                 </a:solidFill>
               </a:rPr>
-              <a:t>Use Governance for High-Risk Capabilities</a:t>
-            </a:r>
-          </a:p>
-        </p:txBody>
-      </p:sp>
-      <p:sp>
-        <p:nvSpPr>
-          <p:cNvPr id="4" name="TextBox 3"/>
+              <a:t>  Least privilege means the connector receives only the access needed for its declared operations. A file...</a:t>
+            </a:r>
+          </a:p>
+        </p:txBody>
+      </p:sp>
+      <p:sp>
+        <p:nvSpPr>
+          <p:cNvPr id="5" name="TextBox 4"/>
           <p:cNvSpPr txBox="1"/>
           <p:nvPr/>
         </p:nvSpPr>
         <p:spPr>
           <a:xfrm>
-            <a:off x="914400" y="1828800"/>
-            <a:ext cx="12801600" cy="5212080"/>
+            <a:off x="731520" y="2651760"/>
+            <a:ext cx="10698480" cy="960120"/>
           </a:xfrm>
           <a:prstGeom prst="rect">
             <a:avLst/>
@@ -3870,82 +3768,33 @@
           <a:noFill/>
         </p:spPr>
         <p:txBody>
-          <a:bodyPr wrap="none">
+          <a:bodyPr wrap="square">
             <a:spAutoFit/>
           </a:bodyPr>
           <a:lstStyle/>
           <a:p>
-            <a:pPr>
-              <a:spcAft>
-                <a:spcPts val="1500"/>
-              </a:spcAft>
-              <a:defRPr sz="2500">
+            <a:pPr algn="l"/>
+            <a:r>
+              <a:rPr sz="1700" b="0">
                 <a:solidFill>
                   <a:srgbClr val="FFFFFF"/>
                 </a:solidFill>
-              </a:defRPr>
-            </a:pPr>
-            <a:r>
-              <a:t>Frontier cyber models make tiered access a practical security requirement.</a:t>
-            </a:r>
-          </a:p>
-          <a:p>
-            <a:pPr>
-              <a:spcAft>
-                <a:spcPts val="1500"/>
-              </a:spcAft>
-              <a:defRPr sz="2500">
-                <a:solidFill>
-                  <a:srgbClr val="FFFFFF"/>
-                </a:solidFill>
-              </a:defRPr>
-            </a:pPr>
-            <a:r>
-              <a:t>Defender verification limits powerful capabilities to vetted organizations.</a:t>
-            </a:r>
-          </a:p>
-          <a:p>
-            <a:pPr>
-              <a:spcAft>
-                <a:spcPts val="1500"/>
-              </a:spcAft>
-              <a:defRPr sz="2500">
-                <a:solidFill>
-                  <a:srgbClr val="FFFFFF"/>
-                </a:solidFill>
-              </a:defRPr>
-            </a:pPr>
-            <a:r>
-              <a:t>Trusted environments can lower refusals only inside verified defensive boundaries.</a:t>
-            </a:r>
-          </a:p>
-          <a:p>
-            <a:pPr>
-              <a:spcAft>
-                <a:spcPts val="1500"/>
-              </a:spcAft>
-              <a:defRPr sz="2500">
-                <a:solidFill>
-                  <a:srgbClr val="FFFFFF"/>
-                </a:solidFill>
-              </a:defRPr>
-            </a:pPr>
-            <a:r>
-              <a:t>High-risk tool calls need tamper-evident audit trails for human and regulator review.</a:t>
-            </a:r>
-          </a:p>
-        </p:txBody>
-      </p:sp>
-      <p:sp>
-        <p:nvSpPr>
-          <p:cNvPr id="5" name="TextBox 4"/>
+              </a:rPr>
+              <a:t>  MCP makes it easy to expose capabilities. That ease is exactly why you must design them narrowly.</a:t>
+            </a:r>
+          </a:p>
+        </p:txBody>
+      </p:sp>
+      <p:sp>
+        <p:nvSpPr>
+          <p:cNvPr id="6" name="TextBox 5"/>
           <p:cNvSpPr txBox="1"/>
           <p:nvPr/>
         </p:nvSpPr>
         <p:spPr>
           <a:xfrm>
-            <a:off x="594360" y="7662672"/>
-            <a:ext cx="13441680" cy="256032"/>
+            <a:off x="731520" y="3703320"/>
+            <a:ext cx="10698480" cy="960120"/>
           </a:xfrm>
           <a:prstGeom prst="rect">
             <a:avLst/>
@@ -3953,14 +3802,48 @@
           <a:noFill/>
         </p:spPr>
         <p:txBody>
-          <a:bodyPr wrap="none">
+          <a:bodyPr wrap="square">
             <a:spAutoFit/>
           </a:bodyPr>
           <a:lstStyle/>
           <a:p>
-            <a:pPr algn="r"/>
-            <a:r>
-              <a:rPr sz="1100">
+            <a:pPr algn="l"/>
+            <a:r>
+              <a:rPr sz="1700" b="0">
+                <a:solidFill>
+                  <a:srgbClr val="FFFFFF"/>
+                </a:solidFill>
+              </a:rPr>
+              <a:t>  Avoid "admin token plus prompt rules" as a security model. Prompt rules are instructions; authorization checks...</a:t>
+            </a:r>
+          </a:p>
+        </p:txBody>
+      </p:sp>
+      <p:sp>
+        <p:nvSpPr>
+          <p:cNvPr id="7" name="TextBox 6"/>
+          <p:cNvSpPr txBox="1"/>
+          <p:nvPr/>
+        </p:nvSpPr>
+        <p:spPr>
+          <a:xfrm>
+            <a:off x="731520" y="6263640"/>
+            <a:ext cx="10698480" cy="365760"/>
+          </a:xfrm>
+          <a:prstGeom prst="rect">
+            <a:avLst/>
+          </a:prstGeom>
+          <a:noFill/>
+        </p:spPr>
+        <p:txBody>
+          <a:bodyPr wrap="square">
+            <a:spAutoFit/>
+          </a:bodyPr>
+          <a:lstStyle/>
+          <a:p>
+            <a:pPr algn="l"/>
+            <a:r>
+              <a:rPr sz="1000" b="0">
                 <a:solidFill>
                   <a:srgbClr val="A1A1AA"/>
                 </a:solidFill>
@@ -3998,20 +3881,54 @@
       <p:grpSpPr/>
       <p:sp>
         <p:nvSpPr>
-          <p:cNvPr id="2" name="Rectangle 1"/>
+          <p:cNvPr id="2" name="TextBox 1"/>
+          <p:cNvSpPr txBox="1"/>
+          <p:nvPr/>
+        </p:nvSpPr>
+        <p:spPr>
+          <a:xfrm>
+            <a:off x="731520" y="411480"/>
+            <a:ext cx="10698480" cy="1005840"/>
+          </a:xfrm>
+          <a:prstGeom prst="rect">
+            <a:avLst/>
+          </a:prstGeom>
+          <a:noFill/>
+        </p:spPr>
+        <p:txBody>
+          <a:bodyPr wrap="square">
+            <a:spAutoFit/>
+          </a:bodyPr>
+          <a:lstStyle/>
+          <a:p>
+            <a:pPr algn="l"/>
+            <a:r>
+              <a:rPr sz="2800" b="1">
+                <a:solidFill>
+                  <a:srgbClr val="FFFFFF"/>
+                </a:solidFill>
+              </a:rPr>
+              <a:t>Authorization wrapper</a:t>
+            </a:r>
+          </a:p>
+        </p:txBody>
+      </p:sp>
+      <p:sp>
+        <p:nvSpPr>
+          <p:cNvPr id="3" name="Rectangle 2"/>
           <p:cNvSpPr/>
           <p:nvPr/>
         </p:nvSpPr>
         <p:spPr>
           <a:xfrm>
-            <a:off x="0" y="0"/>
-            <a:ext cx="146304" cy="8229600"/>
+            <a:off x="731520" y="1417320"/>
+            <a:ext cx="10698480" cy="36576"/>
           </a:xfrm>
           <a:prstGeom prst="rect">
             <a:avLst/>
           </a:prstGeom>
           <a:solidFill>
-            <a:srgbClr val="38BDF8"/>
+            <a:srgbClr val="A1A1AA"/>
           </a:solidFill>
           <a:ln>
             <a:noFill/>
@@ -4041,14 +3958,14 @@
       </p:sp>
       <p:sp>
         <p:nvSpPr>
-          <p:cNvPr id="3" name="TextBox 2"/>
+          <p:cNvPr id="4" name="TextBox 3"/>
           <p:cNvSpPr txBox="1"/>
           <p:nvPr/>
         </p:nvSpPr>
         <p:spPr>
           <a:xfrm>
-            <a:off x="731520" y="594360"/>
-            <a:ext cx="12984480" cy="868680"/>
+            <a:off x="731520" y="1600200"/>
+            <a:ext cx="10698480" cy="960120"/>
           </a:xfrm>
           <a:prstGeom prst="rect">
             <a:avLst/>
@@ -4056,32 +3973,33 @@
           <a:noFill/>
         </p:spPr>
         <p:txBody>
-          <a:bodyPr wrap="none">
+          <a:bodyPr wrap="square">
             <a:spAutoFit/>
           </a:bodyPr>
           <a:lstStyle/>
           <a:p>
-            <a:r>
-              <a:rPr b="1" sz="4000">
+            <a:pPr algn="l"/>
+            <a:r>
+              <a:rPr sz="1700" b="0">
                 <a:solidFill>
                   <a:srgbClr val="FFFFFF"/>
                 </a:solidFill>
               </a:rPr>
-              <a:t>Secure Remote MCP Transports</a:t>
-            </a:r>
-          </a:p>
-        </p:txBody>
-      </p:sp>
-      <p:sp>
-        <p:nvSpPr>
-          <p:cNvPr id="4" name="TextBox 3"/>
+              <a:t>  Put authorization before tool execution and before detailed logging of target data.</a:t>
+            </a:r>
+          </a:p>
+        </p:txBody>
+      </p:sp>
+      <p:sp>
+        <p:nvSpPr>
+          <p:cNvPr id="5" name="TextBox 4"/>
           <p:cNvSpPr txBox="1"/>
           <p:nvPr/>
         </p:nvSpPr>
         <p:spPr>
           <a:xfrm>
-            <a:off x="914400" y="1828800"/>
-            <a:ext cx="12801600" cy="5212080"/>
+            <a:off x="731520" y="2651760"/>
+            <a:ext cx="10698480" cy="960120"/>
           </a:xfrm>
           <a:prstGeom prst="rect">
             <a:avLst/>
@@ -4089,82 +4007,33 @@
           <a:noFill/>
         </p:spPr>
         <p:txBody>
-          <a:bodyPr wrap="none">
+          <a:bodyPr wrap="square">
             <a:spAutoFit/>
           </a:bodyPr>
           <a:lstStyle/>
           <a:p>
-            <a:pPr>
-              <a:spcAft>
-                <a:spcPts val="1500"/>
-              </a:spcAft>
-              <a:defRPr sz="2500">
+            <a:pPr algn="l"/>
+            <a:r>
+              <a:rPr sz="1700" b="0">
                 <a:solidFill>
                   <a:srgbClr val="FFFFFF"/>
                 </a:solidFill>
-              </a:defRPr>
-            </a:pPr>
-            <a:r>
-              <a:t>Local stdio servers inherit the host application permission model.</a:t>
-            </a:r>
-          </a:p>
-          <a:p>
-            <a:pPr>
-              <a:spcAft>
-                <a:spcPts val="1500"/>
-              </a:spcAft>
-              <a:defRPr sz="2500">
-                <a:solidFill>
-                  <a:srgbClr val="FFFFFF"/>
-                </a:solidFill>
-              </a:defRPr>
-            </a:pPr>
-            <a:r>
-              <a:t>Remote HTTP or SSE servers require explicit authentication and transport controls.</a:t>
-            </a:r>
-          </a:p>
-          <a:p>
-            <a:pPr>
-              <a:spcAft>
-                <a:spcPts val="1500"/>
-              </a:spcAft>
-              <a:defRPr sz="2500">
-                <a:solidFill>
-                  <a:srgbClr val="FFFFFF"/>
-                </a:solidFill>
-              </a:defRPr>
-            </a:pPr>
-            <a:r>
-              <a:t>Bearer tokens, secret managers, and OIDC are safer than hardcoded credentials.</a:t>
-            </a:r>
-          </a:p>
-          <a:p>
-            <a:pPr>
-              <a:spcAft>
-                <a:spcPts val="1500"/>
-              </a:spcAft>
-              <a:defRPr sz="2500">
-                <a:solidFill>
-                  <a:srgbClr val="FFFFFF"/>
-                </a:solidFill>
-              </a:defRPr>
-            </a:pPr>
-            <a:r>
-              <a:t>Treat every remote tool call as an authenticated, attributable action.</a:t>
-            </a:r>
-          </a:p>
-        </p:txBody>
-      </p:sp>
-      <p:sp>
-        <p:nvSpPr>
-          <p:cNvPr id="5" name="TextBox 4"/>
+              </a:rPr>
+              <a:t>  roles: string[];</a:t>
+            </a:r>
+          </a:p>
+        </p:txBody>
+      </p:sp>
+      <p:sp>
+        <p:nvSpPr>
+          <p:cNvPr id="6" name="TextBox 5"/>
           <p:cNvSpPr txBox="1"/>
           <p:nvPr/>
         </p:nvSpPr>
         <p:spPr>
           <a:xfrm>
-            <a:off x="594360" y="7662672"/>
-            <a:ext cx="13441680" cy="256032"/>
+            <a:off x="731520" y="3703320"/>
+            <a:ext cx="10698480" cy="960120"/>
           </a:xfrm>
           <a:prstGeom prst="rect">
             <a:avLst/>
@@ -4172,14 +4041,82 @@
           <a:noFill/>
         </p:spPr>
         <p:txBody>
-          <a:bodyPr wrap="none">
+          <a:bodyPr wrap="square">
             <a:spAutoFit/>
           </a:bodyPr>
           <a:lstStyle/>
           <a:p>
-            <a:pPr algn="r"/>
-            <a:r>
-              <a:rPr sz="1100">
+            <a:pPr algn="l"/>
+            <a:r>
+              <a:rPr sz="1700" b="0">
+                <a:solidFill>
+                  <a:srgbClr val="FFFFFF"/>
+                </a:solidFill>
+              </a:rPr>
+              <a:t>  function requirePermission(actor: Actor, permission: string) {</a:t>
+            </a:r>
+          </a:p>
+        </p:txBody>
+      </p:sp>
+      <p:sp>
+        <p:nvSpPr>
+          <p:cNvPr id="7" name="TextBox 6"/>
+          <p:cNvSpPr txBox="1"/>
+          <p:nvPr/>
+        </p:nvSpPr>
+        <p:spPr>
+          <a:xfrm>
+            <a:off x="731520" y="4754880"/>
+            <a:ext cx="10698480" cy="960120"/>
+          </a:xfrm>
+          <a:prstGeom prst="rect">
+            <a:avLst/>
+          </a:prstGeom>
+          <a:noFill/>
+        </p:spPr>
+        <p:txBody>
+          <a:bodyPr wrap="square">
+            <a:spAutoFit/>
+          </a:bodyPr>
+          <a:lstStyle/>
+          <a:p>
+            <a:pPr algn="l"/>
+            <a:r>
+              <a:rPr sz="1700" b="0">
+                <a:solidFill>
+                  <a:srgbClr val="FFFFFF"/>
+                </a:solidFill>
+              </a:rPr>
+              <a:t>  if (!actor.roles.includes(permission)) {</a:t>
+            </a:r>
+          </a:p>
+        </p:txBody>
+      </p:sp>
+      <p:sp>
+        <p:nvSpPr>
+          <p:cNvPr id="8" name="TextBox 7"/>
+          <p:cNvSpPr txBox="1"/>
+          <p:nvPr/>
+        </p:nvSpPr>
+        <p:spPr>
+          <a:xfrm>
+            <a:off x="731520" y="6263640"/>
+            <a:ext cx="10698480" cy="365760"/>
+          </a:xfrm>
+          <a:prstGeom prst="rect">
+            <a:avLst/>
+          </a:prstGeom>
+          <a:noFill/>
+        </p:spPr>
+        <p:txBody>
+          <a:bodyPr wrap="square">
+            <a:spAutoFit/>
+          </a:bodyPr>
+          <a:lstStyle/>
+          <a:p>
+            <a:pPr algn="l"/>
+            <a:r>
+              <a:rPr sz="1000" b="0">
                 <a:solidFill>
                   <a:srgbClr val="A1A1AA"/>
                 </a:solidFill>
@@ -4217,20 +4154,54 @@
       <p:grpSpPr/>
       <p:sp>
         <p:nvSpPr>
-          <p:cNvPr id="2" name="Rectangle 1"/>
+          <p:cNvPr id="2" name="TextBox 1"/>
+          <p:cNvSpPr txBox="1"/>
+          <p:nvPr/>
+        </p:nvSpPr>
+        <p:spPr>
+          <a:xfrm>
+            <a:off x="731520" y="411480"/>
+            <a:ext cx="10698480" cy="1005840"/>
+          </a:xfrm>
+          <a:prstGeom prst="rect">
+            <a:avLst/>
+          </a:prstGeom>
+          <a:noFill/>
+        </p:spPr>
+        <p:txBody>
+          <a:bodyPr wrap="square">
+            <a:spAutoFit/>
+          </a:bodyPr>
+          <a:lstStyle/>
+          <a:p>
+            <a:pPr algn="l"/>
+            <a:r>
+              <a:rPr sz="2800" b="1">
+                <a:solidFill>
+                  <a:srgbClr val="FFFFFF"/>
+                </a:solidFill>
+              </a:rPr>
+              <a:t>Human-in-the-loop approval</a:t>
+            </a:r>
+          </a:p>
+        </p:txBody>
+      </p:sp>
+      <p:sp>
+        <p:nvSpPr>
+          <p:cNvPr id="3" name="Rectangle 2"/>
           <p:cNvSpPr/>
           <p:nvPr/>
         </p:nvSpPr>
         <p:spPr>
           <a:xfrm>
-            <a:off x="0" y="0"/>
-            <a:ext cx="146304" cy="8229600"/>
+            <a:off x="731520" y="1417320"/>
+            <a:ext cx="10698480" cy="36576"/>
           </a:xfrm>
           <a:prstGeom prst="rect">
             <a:avLst/>
           </a:prstGeom>
           <a:solidFill>
-            <a:srgbClr val="38BDF8"/>
+            <a:srgbClr val="A1A1AA"/>
           </a:solidFill>
           <a:ln>
             <a:noFill/>
@@ -4260,14 +4231,14 @@
       </p:sp>
       <p:sp>
         <p:nvSpPr>
-          <p:cNvPr id="3" name="TextBox 2"/>
+          <p:cNvPr id="4" name="TextBox 3"/>
           <p:cNvSpPr txBox="1"/>
           <p:nvPr/>
         </p:nvSpPr>
         <p:spPr>
           <a:xfrm>
-            <a:off x="731520" y="594360"/>
-            <a:ext cx="12984480" cy="868680"/>
+            <a:off x="731520" y="1600200"/>
+            <a:ext cx="10698480" cy="960120"/>
           </a:xfrm>
           <a:prstGeom prst="rect">
             <a:avLst/>
@@ -4275,32 +4246,33 @@
           <a:noFill/>
         </p:spPr>
         <p:txBody>
-          <a:bodyPr wrap="none">
+          <a:bodyPr wrap="square">
             <a:spAutoFit/>
           </a:bodyPr>
           <a:lstStyle/>
           <a:p>
-            <a:r>
-              <a:rPr b="1" sz="4000">
+            <a:pPr algn="l"/>
+            <a:r>
+              <a:rPr sz="1700" b="0">
                 <a:solidFill>
                   <a:srgbClr val="FFFFFF"/>
                 </a:solidFill>
               </a:rPr>
-              <a:t>Build a Vetted Audit Trail</a:t>
-            </a:r>
-          </a:p>
-        </p:txBody>
-      </p:sp>
-      <p:sp>
-        <p:nvSpPr>
-          <p:cNvPr id="4" name="TextBox 3"/>
+              <a:t>  Some tools should not execute immediately even when authorized. Approval gates are appropriate when a tool...</a:t>
+            </a:r>
+          </a:p>
+        </p:txBody>
+      </p:sp>
+      <p:sp>
+        <p:nvSpPr>
+          <p:cNvPr id="5" name="TextBox 4"/>
           <p:cNvSpPr txBox="1"/>
           <p:nvPr/>
         </p:nvSpPr>
         <p:spPr>
           <a:xfrm>
-            <a:off x="914400" y="1828800"/>
-            <a:ext cx="12801600" cy="5212080"/>
+            <a:off x="731520" y="2651760"/>
+            <a:ext cx="10698480" cy="960120"/>
           </a:xfrm>
           <a:prstGeom prst="rect">
             <a:avLst/>
@@ -4308,82 +4280,33 @@
           <a:noFill/>
         </p:spPr>
         <p:txBody>
-          <a:bodyPr wrap="none">
+          <a:bodyPr wrap="square">
             <a:spAutoFit/>
           </a:bodyPr>
           <a:lstStyle/>
           <a:p>
-            <a:pPr>
-              <a:spcAft>
-                <a:spcPts val="1500"/>
-              </a:spcAft>
-              <a:defRPr sz="2500">
+            <a:pPr algn="l"/>
+            <a:r>
+              <a:rPr sz="1700" b="0">
                 <a:solidFill>
                   <a:srgbClr val="FFFFFF"/>
                 </a:solidFill>
-              </a:defRPr>
-            </a:pPr>
-            <a:r>
-              <a:t>Scope the file-system server to a specific /data/sandbox directory.</a:t>
-            </a:r>
-          </a:p>
-          <a:p>
-            <a:pPr>
-              <a:spcAft>
-                <a:spcPts val="1500"/>
-              </a:spcAft>
-              <a:defRPr sz="2500">
-                <a:solidFill>
-                  <a:srgbClr val="FFFFFF"/>
-                </a:solidFill>
-              </a:defRPr>
-            </a:pPr>
-            <a:r>
-              <a:t>Log timestamp, tool name, scrubbed input arguments, and outcome for every call.</a:t>
-            </a:r>
-          </a:p>
-          <a:p>
-            <a:pPr>
-              <a:spcAft>
-                <a:spcPts val="1500"/>
-              </a:spcAft>
-              <a:defRPr sz="2500">
-                <a:solidFill>
-                  <a:srgbClr val="FFFFFF"/>
-                </a:solidFill>
-              </a:defRPr>
-            </a:pPr>
-            <a:r>
-              <a:t>Record both successful operations and rejected out-of-scope access attempts.</a:t>
-            </a:r>
-          </a:p>
-          <a:p>
-            <a:pPr>
-              <a:spcAft>
-                <a:spcPts val="1500"/>
-              </a:spcAft>
-              <a:defRPr sz="2500">
-                <a:solidFill>
-                  <a:srgbClr val="FFFFFF"/>
-                </a:solidFill>
-              </a:defRPr>
-            </a:pPr>
-            <a:r>
-              <a:t>Automate real-time audit verification instead of relying on weekly manual review.</a:t>
-            </a:r>
-          </a:p>
-        </p:txBody>
-      </p:sp>
-      <p:sp>
-        <p:nvSpPr>
-          <p:cNvPr id="5" name="TextBox 4"/>
+              </a:rPr>
+              <a:t>  A safe tool can return a pending action:</a:t>
+            </a:r>
+          </a:p>
+        </p:txBody>
+      </p:sp>
+      <p:sp>
+        <p:nvSpPr>
+          <p:cNvPr id="6" name="TextBox 5"/>
           <p:cNvSpPr txBox="1"/>
           <p:nvPr/>
         </p:nvSpPr>
         <p:spPr>
           <a:xfrm>
-            <a:off x="594360" y="7662672"/>
-            <a:ext cx="13441680" cy="256032"/>
+            <a:off x="731520" y="3703320"/>
+            <a:ext cx="10698480" cy="960120"/>
           </a:xfrm>
           <a:prstGeom prst="rect">
             <a:avLst/>
@@ -4391,14 +4314,82 @@
           <a:noFill/>
         </p:spPr>
         <p:txBody>
-          <a:bodyPr wrap="none">
+          <a:bodyPr wrap="square">
             <a:spAutoFit/>
           </a:bodyPr>
           <a:lstStyle/>
           <a:p>
-            <a:pPr algn="r"/>
-            <a:r>
-              <a:rPr sz="1100">
+            <a:pPr algn="l"/>
+            <a:r>
+              <a:rPr sz="1700" b="0">
+                <a:solidFill>
+                  <a:srgbClr val="FFFFFF"/>
+                </a:solidFill>
+              </a:rPr>
+              <a:t>  "status": "awaiting_approval",</a:t>
+            </a:r>
+          </a:p>
+        </p:txBody>
+      </p:sp>
+      <p:sp>
+        <p:nvSpPr>
+          <p:cNvPr id="7" name="TextBox 6"/>
+          <p:cNvSpPr txBox="1"/>
+          <p:nvPr/>
+        </p:nvSpPr>
+        <p:spPr>
+          <a:xfrm>
+            <a:off x="731520" y="4754880"/>
+            <a:ext cx="10698480" cy="960120"/>
+          </a:xfrm>
+          <a:prstGeom prst="rect">
+            <a:avLst/>
+          </a:prstGeom>
+          <a:noFill/>
+        </p:spPr>
+        <p:txBody>
+          <a:bodyPr wrap="square">
+            <a:spAutoFit/>
+          </a:bodyPr>
+          <a:lstStyle/>
+          <a:p>
+            <a:pPr algn="l"/>
+            <a:r>
+              <a:rPr sz="1700" b="0">
+                <a:solidFill>
+                  <a:srgbClr val="FFFFFF"/>
+                </a:solidFill>
+              </a:rPr>
+              <a:t>  "action": "send_invoice_reminder",</a:t>
+            </a:r>
+          </a:p>
+        </p:txBody>
+      </p:sp>
+      <p:sp>
+        <p:nvSpPr>
+          <p:cNvPr id="8" name="TextBox 7"/>
+          <p:cNvSpPr txBox="1"/>
+          <p:nvPr/>
+        </p:nvSpPr>
+        <p:spPr>
+          <a:xfrm>
+            <a:off x="731520" y="6263640"/>
+            <a:ext cx="10698480" cy="365760"/>
+          </a:xfrm>
+          <a:prstGeom prst="rect">
+            <a:avLst/>
+          </a:prstGeom>
+          <a:noFill/>
+        </p:spPr>
+        <p:txBody>
+          <a:bodyPr wrap="square">
+            <a:spAutoFit/>
+          </a:bodyPr>
+          <a:lstStyle/>
+          <a:p>
+            <a:pPr algn="l"/>
+            <a:r>
+              <a:rPr sz="1000" b="0">
                 <a:solidFill>
                   <a:srgbClr val="A1A1AA"/>
                 </a:solidFill>
@@ -4436,57 +4427,14 @@
       <p:grpSpPr/>
       <p:sp>
         <p:nvSpPr>
-          <p:cNvPr id="2" name="Rectangle 1"/>
-          <p:cNvSpPr/>
-          <p:nvPr/>
-        </p:nvSpPr>
-        <p:spPr>
-          <a:xfrm>
-            <a:off x="0" y="0"/>
-            <a:ext cx="146304" cy="8229600"/>
-          </a:xfrm>
-          <a:prstGeom prst="rect">
-            <a:avLst/>
-          </a:prstGeom>
-          <a:solidFill>
-            <a:srgbClr val="FBBF24"/>
-          </a:solidFill>
-          <a:ln>
-            <a:noFill/>
-          </a:ln>
-        </p:spPr>
-        <p:style>
-          <a:lnRef idx="1">
-            <a:schemeClr val="accent1"/>
-          </a:lnRef>
-          <a:fillRef idx="3">
-            <a:schemeClr val="accent1"/>
-          </a:fillRef>
-          <a:effectRef idx="2">
-            <a:schemeClr val="accent1"/>
-          </a:effectRef>
-          <a:fontRef idx="minor">
-            <a:schemeClr val="lt1"/>
-          </a:fontRef>
-        </p:style>
-        <p:txBody>
-          <a:bodyPr rtlCol="0" anchor="ctr"/>
-          <a:lstStyle/>
-          <a:p>
-            <a:pPr algn="ctr"/>
-          </a:p>
-        </p:txBody>
-      </p:sp>
-      <p:sp>
-        <p:nvSpPr>
-          <p:cNvPr id="3" name="TextBox 2"/>
+          <p:cNvPr id="2" name="TextBox 1"/>
           <p:cNvSpPr txBox="1"/>
           <p:nvPr/>
         </p:nvSpPr>
         <p:spPr>
           <a:xfrm>
-            <a:off x="731520" y="594360"/>
-            <a:ext cx="12984480" cy="868680"/>
+            <a:off x="914400" y="2011680"/>
+            <a:ext cx="10332720" cy="914400"/>
           </a:xfrm>
           <a:prstGeom prst="rect">
             <a:avLst/>
@@ -4494,13 +4442,14 @@
           <a:noFill/>
         </p:spPr>
         <p:txBody>
-          <a:bodyPr wrap="none">
+          <a:bodyPr wrap="square">
             <a:spAutoFit/>
           </a:bodyPr>
           <a:lstStyle/>
           <a:p>
-            <a:r>
-              <a:rPr b="1" sz="4000">
+            <a:pPr algn="ctr"/>
+            <a:r>
+              <a:rPr sz="3400" b="1">
                 <a:solidFill>
                   <a:srgbClr val="FFFFFF"/>
                 </a:solidFill>
@@ -4512,14 +4461,14 @@
       </p:sp>
       <p:sp>
         <p:nvSpPr>
-          <p:cNvPr id="4" name="TextBox 3"/>
+          <p:cNvPr id="3" name="TextBox 2"/>
           <p:cNvSpPr txBox="1"/>
           <p:nvPr/>
         </p:nvSpPr>
         <p:spPr>
           <a:xfrm>
-            <a:off x="914400" y="1828800"/>
-            <a:ext cx="12801600" cy="5212080"/>
+            <a:off x="914400" y="3200400"/>
+            <a:ext cx="10332720" cy="1097280"/>
           </a:xfrm>
           <a:prstGeom prst="rect">
             <a:avLst/>
@@ -4527,82 +4476,33 @@
           <a:noFill/>
         </p:spPr>
         <p:txBody>
-          <a:bodyPr wrap="none">
+          <a:bodyPr wrap="square">
             <a:spAutoFit/>
           </a:bodyPr>
           <a:lstStyle/>
           <a:p>
-            <a:pPr>
-              <a:spcAft>
-                <a:spcPts val="1500"/>
-              </a:spcAft>
-              <a:defRPr sz="2500">
-                <a:solidFill>
-                  <a:srgbClr val="FFFFFF"/>
-                </a:solidFill>
-              </a:defRPr>
-            </a:pPr>
-            <a:r>
-              <a:t>Take your Chapter 3 file-system MCP server and add a governance layer.</a:t>
-            </a:r>
-          </a:p>
-          <a:p>
-            <a:pPr>
-              <a:spcAft>
-                <a:spcPts val="1500"/>
-              </a:spcAft>
-              <a:defRPr sz="2500">
-                <a:solidFill>
-                  <a:srgbClr val="FFFFFF"/>
-                </a:solidFill>
-              </a:defRPr>
-            </a:pPr>
-            <a:r>
-              <a:t>Confirm one allowed file access and one denied out-of-scope access.</a:t>
-            </a:r>
-          </a:p>
-          <a:p>
-            <a:pPr>
-              <a:spcAft>
-                <a:spcPts val="1500"/>
-              </a:spcAft>
-              <a:defRPr sz="2500">
-                <a:solidFill>
-                  <a:srgbClr val="FFFFFF"/>
-                </a:solidFill>
-              </a:defRPr>
-            </a:pPr>
-            <a:r>
-              <a:t>Inspect audit.log for timestamp, tool name, scrubbed arguments, and outcome.</a:t>
-            </a:r>
-          </a:p>
-          <a:p>
-            <a:pPr>
-              <a:spcAft>
-                <a:spcPts val="1500"/>
-              </a:spcAft>
-              <a:defRPr sz="2500">
-                <a:solidFill>
-                  <a:srgbClr val="FFFFFF"/>
-                </a:solidFill>
-              </a:defRPr>
-            </a:pPr>
-            <a:r>
-              <a:t>In Chapter 7: manage creative context without compromising security.</a:t>
-            </a:r>
-          </a:p>
-        </p:txBody>
-      </p:sp>
-      <p:sp>
-        <p:nvSpPr>
-          <p:cNvPr id="5" name="TextBox 4"/>
+            <a:pPr algn="ctr"/>
+            <a:r>
+              <a:rPr sz="2000" b="0">
+                <a:solidFill>
+                  <a:srgbClr val="A1A1AA"/>
+                </a:solidFill>
+              </a:rPr>
+              <a:t>Deploy a gateway with RBAC, rate limits, and JSONL auditing</a:t>
+            </a:r>
+          </a:p>
+        </p:txBody>
+      </p:sp>
+      <p:sp>
+        <p:nvSpPr>
+          <p:cNvPr id="4" name="TextBox 3"/>
           <p:cNvSpPr txBox="1"/>
           <p:nvPr/>
         </p:nvSpPr>
         <p:spPr>
           <a:xfrm>
-            <a:off x="594360" y="7662672"/>
-            <a:ext cx="13441680" cy="256032"/>
+            <a:off x="731520" y="6263640"/>
+            <a:ext cx="10698480" cy="365760"/>
           </a:xfrm>
           <a:prstGeom prst="rect">
             <a:avLst/>
@@ -4610,14 +4510,14 @@
           <a:noFill/>
         </p:spPr>
         <p:txBody>
-          <a:bodyPr wrap="none">
+          <a:bodyPr wrap="square">
             <a:spAutoFit/>
           </a:bodyPr>
           <a:lstStyle/>
           <a:p>
-            <a:pPr algn="r"/>
-            <a:r>
-              <a:rPr sz="1100">
+            <a:pPr algn="l"/>
+            <a:r>
+              <a:rPr sz="1000" b="0">
                 <a:solidFill>
                   <a:srgbClr val="A1A1AA"/>
                 </a:solidFill>

</xml_diff>

<commit_message>
fix(slides): KOEA-8269 — add 4 overview bullets to ch06 Slide 1
Slide 1 was title-only (0 content bullets). G0 criterion requires 3-5
substantive bullets. Repositioned title to section-header position,
added horizontal rule, and added 4 learning-objective bullets:
- Distinguish authentication from authorization in MCP connectors
- Apply least privilege at both credential level and tool scope
- Add an authorization wrapper to enforce per-tool permissions in code
- Design a human approval gate for high-risk actions

Slide count remains 7. Attribution still appears once on Slide 1 only.

Co-Authored-By: Claude Sonnet 4.6 <noreply@anthropic.com>
</commit_message>
<xml_diff>
--- a/vault/courses/claude-tool-use-from-zero/ch06-slides.pptx
+++ b/vault/courses/claude-tool-use-from-zero/ch06-slides.pptx
@@ -3110,8 +3110,8 @@
         </p:nvSpPr>
         <p:spPr>
           <a:xfrm>
-            <a:off x="914400" y="1828800"/>
-            <a:ext cx="10332720" cy="2286000"/>
+            <a:off x="731520" y="411480"/>
+            <a:ext cx="10698480" cy="1005840"/>
           </a:xfrm>
           <a:prstGeom prst="rect">
             <a:avLst/>
@@ -3126,7 +3126,7 @@
           <a:p>
             <a:pPr algn="ctr"/>
             <a:r>
-              <a:rPr sz="3400" b="1">
+              <a:rPr sz="2800" b="1">
                 <a:solidFill>
                   <a:srgbClr val="FFFFFF"/>
                 </a:solidFill>
@@ -3166,6 +3166,181 @@
                 </a:solidFill>
               </a:rPr>
               <a:t>academy.kspl.tech | Koenig AI Academy</a:t>
+            </a:r>
+          </a:p>
+        </p:txBody>
+      </p:sp>
+      <p:sp>
+        <p:nvSpPr>
+          <p:cNvPr id="4" name="Rectangle 3"/>
+          <p:cNvSpPr/>
+          <p:nvPr/>
+        </p:nvSpPr>
+        <p:spPr>
+          <a:xfrm>
+            <a:off x="731520" y="1417320"/>
+            <a:ext cx="10698480" cy="36576"/>
+          </a:xfrm>
+          <a:prstGeom prst="rect">
+            <a:avLst/>
+          </a:prstGeom>
+          <a:solidFill>
+            <a:srgbClr val="A1A1AA"/>
+          </a:solidFill>
+          <a:ln>
+            <a:noFill/>
+          </a:ln>
+        </p:spPr>
+        <p:style>
+          <a:lnRef idx="1">
+            <a:schemeClr val="accent1"/>
+          </a:lnRef>
+          <a:fillRef idx="3">
+            <a:schemeClr val="accent1"/>
+          </a:fillRef>
+          <a:effectRef idx="2">
+            <a:schemeClr val="accent1"/>
+          </a:effectRef>
+          <a:fontRef idx="minor">
+            <a:schemeClr val="lt1"/>
+          </a:fontRef>
+        </p:style>
+        <p:txBody>
+          <a:bodyPr rtlCol="0" anchor="ctr"/>
+          <a:lstStyle/>
+          <a:p>
+            <a:pPr algn="ctr"/>
+          </a:p>
+        </p:txBody>
+      </p:sp>
+      <p:sp>
+        <p:nvSpPr>
+          <p:cNvPr id="5" name="TextBox 4"/>
+          <p:cNvSpPr txBox="1"/>
+          <p:nvPr/>
+        </p:nvSpPr>
+        <p:spPr>
+          <a:xfrm>
+            <a:off x="731520" y="1600200"/>
+            <a:ext cx="10698480" cy="960120"/>
+          </a:xfrm>
+          <a:prstGeom prst="rect">
+            <a:avLst/>
+          </a:prstGeom>
+          <a:noFill/>
+        </p:spPr>
+        <p:txBody>
+          <a:bodyPr wrap="square">
+            <a:spAutoFit/>
+          </a:bodyPr>
+          <a:lstStyle/>
+          <a:p>
+            <a:r>
+              <a:rPr sz="1700" b="0">
+                <a:solidFill>
+                  <a:srgbClr val="FFFFFF"/>
+                </a:solidFill>
+              </a:rPr>
+              <a:t>  Distinguish authentication from authorization in MCP connectors</a:t>
+            </a:r>
+          </a:p>
+        </p:txBody>
+      </p:sp>
+      <p:sp>
+        <p:nvSpPr>
+          <p:cNvPr id="6" name="TextBox 5"/>
+          <p:cNvSpPr txBox="1"/>
+          <p:nvPr/>
+        </p:nvSpPr>
+        <p:spPr>
+          <a:xfrm>
+            <a:off x="731520" y="2651760"/>
+            <a:ext cx="10698480" cy="960120"/>
+          </a:xfrm>
+          <a:prstGeom prst="rect">
+            <a:avLst/>
+          </a:prstGeom>
+          <a:noFill/>
+        </p:spPr>
+        <p:txBody>
+          <a:bodyPr wrap="square">
+            <a:spAutoFit/>
+          </a:bodyPr>
+          <a:lstStyle/>
+          <a:p>
+            <a:r>
+              <a:rPr sz="1700" b="0">
+                <a:solidFill>
+                  <a:srgbClr val="FFFFFF"/>
+                </a:solidFill>
+              </a:rPr>
+              <a:t>  Apply least privilege at both credential level and individual tool scope</a:t>
+            </a:r>
+          </a:p>
+        </p:txBody>
+      </p:sp>
+      <p:sp>
+        <p:nvSpPr>
+          <p:cNvPr id="7" name="TextBox 6"/>
+          <p:cNvSpPr txBox="1"/>
+          <p:nvPr/>
+        </p:nvSpPr>
+        <p:spPr>
+          <a:xfrm>
+            <a:off x="731520" y="3703320"/>
+            <a:ext cx="10698480" cy="960120"/>
+          </a:xfrm>
+          <a:prstGeom prst="rect">
+            <a:avLst/>
+          </a:prstGeom>
+          <a:noFill/>
+        </p:spPr>
+        <p:txBody>
+          <a:bodyPr wrap="square">
+            <a:spAutoFit/>
+          </a:bodyPr>
+          <a:lstStyle/>
+          <a:p>
+            <a:r>
+              <a:rPr sz="1700" b="0">
+                <a:solidFill>
+                  <a:srgbClr val="FFFFFF"/>
+                </a:solidFill>
+              </a:rPr>
+              <a:t>  Add an authorization wrapper to enforce per-tool permissions in code</a:t>
+            </a:r>
+          </a:p>
+        </p:txBody>
+      </p:sp>
+      <p:sp>
+        <p:nvSpPr>
+          <p:cNvPr id="8" name="TextBox 7"/>
+          <p:cNvSpPr txBox="1"/>
+          <p:nvPr/>
+        </p:nvSpPr>
+        <p:spPr>
+          <a:xfrm>
+            <a:off x="731520" y="4754880"/>
+            <a:ext cx="10698480" cy="960120"/>
+          </a:xfrm>
+          <a:prstGeom prst="rect">
+            <a:avLst/>
+          </a:prstGeom>
+          <a:noFill/>
+        </p:spPr>
+        <p:txBody>
+          <a:bodyPr wrap="square">
+            <a:spAutoFit/>
+          </a:bodyPr>
+          <a:lstStyle/>
+          <a:p>
+            <a:r>
+              <a:rPr sz="1700" b="0">
+                <a:solidFill>
+                  <a:srgbClr val="FFFFFF"/>
+                </a:solidFill>
+              </a:rPr>
+              <a:t>  Design a human approval gate for high-risk actions (payments, emails, deletions)</a:t>
             </a:r>
           </a:p>
         </p:txBody>

</xml_diff>